<commit_message>
Correct slides 9, 16 and 18 of the CEO update deck
Mention & Win views 26.3K, Manal Talal 22 Oct, paid media 'testing' not
'launched', LinkedIn +6,075% stated as new-follower growth, referral 32
(5.5%) with ChatGPT moved to the footnote (572 of 587, 97.4%).

Co-Authored-By: Claude Opus 5.5 <noreply@anthropic.com>
Claude-Session: https://claude.ai/code/session_01SNf1Edf2HMYqmZpheYf6i6
</commit_message>
<xml_diff>
--- a/emyaa-ceo-deck/output/ceo-update/eMYAA_Performance_Analysis_-_01.10.2026_-_Updated_29_Sep.pptx
+++ b/emyaa-ceo-deck/output/ceo-update/eMYAA_Performance_Analysis_-_01.10.2026_-_Updated_29_Sep.pptx
@@ -23569,7 +23569,7 @@
                           <a:cs typeface="Exo 2"/>
                           <a:sym typeface="Exo 2"/>
                         </a:rPr>
-                        <a:t>Followers up 247 in 30 days (+6,075%); 13-27 Sep: 559 impressions (+118%), 28 reactions (+155%)</a:t>
+                        <a:t>247 new followers in 30 days (vs 4 before, +6,075%); 13-27 Sep: 559 impressions (+118%), 28 reactions (+155%)</a:t>
                       </a:r>
                       <a:endParaRPr lang="en-US" sz="1100"/>
                     </a:p>
@@ -25895,7 +25895,7 @@
                           <a:cs typeface="Exo 2"/>
                           <a:sym typeface="Exo 2"/>
                         </a:rPr>
-                        <a:t>google / cpc, new campaign launched 22 Sep, already the top traffic source</a:t>
+                        <a:t>google / cpc, campaign live since 22 Sep, already the top traffic source</a:t>
                       </a:r>
                       <a:endParaRPr lang="en-US" sz="1100"/>
                     </a:p>
@@ -26481,7 +26481,7 @@
                           <a:cs typeface="Exo 2"/>
                           <a:sym typeface="Exo 2"/>
                         </a:rPr>
-                        <a:t>39 (6.6%)</a:t>
+                        <a:t>32 (5.5%)</a:t>
                       </a:r>
                       <a:endParaRPr lang="en-US" sz="1100"/>
                     </a:p>
@@ -26552,7 +26552,7 @@
                           <a:cs typeface="Exo 2"/>
                           <a:sym typeface="Exo 2"/>
                         </a:rPr>
-                        <a:t>ajyadcapital.com, Instagram, ChatGPT, Google Tag Assistant</a:t>
+                        <a:t>ajyadcapital.com, Instagram, Facebook, Google Tag Assistant (7 test visits)</a:t>
                       </a:r>
                       <a:endParaRPr lang="en-US" sz="1100"/>
                     </a:p>
@@ -27075,7 +27075,7 @@
                 </a:solidFill>
                 <a:latin typeface="Calibri"/>
               </a:rPr>
-              <a:t>The four sources above account for 579 of the site’s 587 tracked sessions (98.6%); the remaining 8 sessions (1.4%) fall outside GA’s top-traffic breakdown.</a:t>
+              <a:t>The four sources above account for 572 of the site’s 587 sessions (97.4%); the other 15 are ChatGPT (9) and source not available (6). GA4 export, 1-28 Sep.</a:t>
             </a:r>
           </a:p>
         </p:txBody>
@@ -54963,7 +54963,7 @@
                           <a:cs typeface="Exo 2"/>
                           <a:sym typeface="Exo 2"/>
                         </a:rPr>
-                        <a:t>Timed before salary days; 26.2K views, 1,129 likes on launch reel</a:t>
+                        <a:t>Timed before salary days; 26.3K views, 1,129 likes on launch post</a:t>
                       </a:r>
                       <a:endParaRPr lang="en-US" sz="1100"/>
                     </a:p>
@@ -56402,7 +56402,7 @@
                           <a:cs typeface="Exo 2"/>
                           <a:sym typeface="Exo 2"/>
                         </a:rPr>
-                        <a:t>Scheduled for end of October</a:t>
+                        <a:t>Scheduled for 22 October</a:t>
                       </a:r>
                       <a:endParaRPr lang="en-US" sz="1100" dirty="0"/>
                     </a:p>
@@ -56649,7 +56649,7 @@
                 </a:solidFill>
                 <a:latin typeface="Calibri"/>
               </a:rPr>
-              <a:t>Launched 22 Sep, testing phase. Google Search (Starter/Emerging) + LinkedIn lead gen (Affluent). Interest targeting: Saudi Arabia and Riyadh; location restricted to Saudi Arabia residents only. $30,000 campaign, Sep to Dec (Ignite, TI7541).</a:t>
+              <a:t>Testing since 22 Sep. Google Search (Starter/Emerging) + LinkedIn lead gen (Affluent). Interest targeting: Saudi Arabia and Riyadh; location restricted to Saudi Arabia residents only. $30,000 campaign, Sep to Dec (Ignite, TI7541).</a:t>
             </a:r>
           </a:p>
           <a:p>

</xml_diff>